<commit_message>
done base line backend
</commit_message>
<xml_diff>
--- a/TV_AI_AGENT/backend/template/second_testing_template.pptx
+++ b/TV_AI_AGENT/backend/template/second_testing_template.pptx
@@ -313,7 +313,7 @@
             <a:fld id="{1D8BD707-D9CF-40AE-B4C6-C98DA3205C09}" type="datetimeFigureOut">
               <a:rPr lang="en-US" smtClean="0"/>
               <a:pPr/>
-              <a:t>3/27/2026</a:t>
+              <a:t>3/28/2026</a:t>
             </a:fld>
             <a:endParaRPr lang="en-US"/>
           </a:p>
@@ -478,7 +478,7 @@
             <a:fld id="{1D8BD707-D9CF-40AE-B4C6-C98DA3205C09}" type="datetimeFigureOut">
               <a:rPr lang="en-US" smtClean="0"/>
               <a:pPr/>
-              <a:t>3/27/2026</a:t>
+              <a:t>3/28/2026</a:t>
             </a:fld>
             <a:endParaRPr lang="en-US"/>
           </a:p>
@@ -653,7 +653,7 @@
             <a:fld id="{1D8BD707-D9CF-40AE-B4C6-C98DA3205C09}" type="datetimeFigureOut">
               <a:rPr lang="en-US" smtClean="0"/>
               <a:pPr/>
-              <a:t>3/27/2026</a:t>
+              <a:t>3/28/2026</a:t>
             </a:fld>
             <a:endParaRPr lang="en-US"/>
           </a:p>
@@ -818,7 +818,7 @@
             <a:fld id="{1D8BD707-D9CF-40AE-B4C6-C98DA3205C09}" type="datetimeFigureOut">
               <a:rPr lang="en-US" smtClean="0"/>
               <a:pPr/>
-              <a:t>3/27/2026</a:t>
+              <a:t>3/28/2026</a:t>
             </a:fld>
             <a:endParaRPr lang="en-US"/>
           </a:p>
@@ -1060,7 +1060,7 @@
             <a:fld id="{1D8BD707-D9CF-40AE-B4C6-C98DA3205C09}" type="datetimeFigureOut">
               <a:rPr lang="en-US" smtClean="0"/>
               <a:pPr/>
-              <a:t>3/27/2026</a:t>
+              <a:t>3/28/2026</a:t>
             </a:fld>
             <a:endParaRPr lang="en-US"/>
           </a:p>
@@ -1342,7 +1342,7 @@
             <a:fld id="{1D8BD707-D9CF-40AE-B4C6-C98DA3205C09}" type="datetimeFigureOut">
               <a:rPr lang="en-US" smtClean="0"/>
               <a:pPr/>
-              <a:t>3/27/2026</a:t>
+              <a:t>3/28/2026</a:t>
             </a:fld>
             <a:endParaRPr lang="en-US"/>
           </a:p>
@@ -1758,7 +1758,7 @@
             <a:fld id="{1D8BD707-D9CF-40AE-B4C6-C98DA3205C09}" type="datetimeFigureOut">
               <a:rPr lang="en-US" smtClean="0"/>
               <a:pPr/>
-              <a:t>3/27/2026</a:t>
+              <a:t>3/28/2026</a:t>
             </a:fld>
             <a:endParaRPr lang="en-US"/>
           </a:p>
@@ -1872,7 +1872,7 @@
             <a:fld id="{1D8BD707-D9CF-40AE-B4C6-C98DA3205C09}" type="datetimeFigureOut">
               <a:rPr lang="en-US" smtClean="0"/>
               <a:pPr/>
-              <a:t>3/27/2026</a:t>
+              <a:t>3/28/2026</a:t>
             </a:fld>
             <a:endParaRPr lang="en-US"/>
           </a:p>
@@ -1964,7 +1964,7 @@
             <a:fld id="{1D8BD707-D9CF-40AE-B4C6-C98DA3205C09}" type="datetimeFigureOut">
               <a:rPr lang="en-US" smtClean="0"/>
               <a:pPr/>
-              <a:t>3/27/2026</a:t>
+              <a:t>3/28/2026</a:t>
             </a:fld>
             <a:endParaRPr lang="en-US"/>
           </a:p>
@@ -2236,7 +2236,7 @@
             <a:fld id="{1D8BD707-D9CF-40AE-B4C6-C98DA3205C09}" type="datetimeFigureOut">
               <a:rPr lang="en-US" smtClean="0"/>
               <a:pPr/>
-              <a:t>3/27/2026</a:t>
+              <a:t>3/28/2026</a:t>
             </a:fld>
             <a:endParaRPr lang="en-US"/>
           </a:p>
@@ -2485,7 +2485,7 @@
             <a:fld id="{1D8BD707-D9CF-40AE-B4C6-C98DA3205C09}" type="datetimeFigureOut">
               <a:rPr lang="en-US" smtClean="0"/>
               <a:pPr/>
-              <a:t>3/27/2026</a:t>
+              <a:t>3/28/2026</a:t>
             </a:fld>
             <a:endParaRPr lang="en-US"/>
           </a:p>
@@ -2693,7 +2693,7 @@
             <a:fld id="{1D8BD707-D9CF-40AE-B4C6-C98DA3205C09}" type="datetimeFigureOut">
               <a:rPr lang="en-US" smtClean="0"/>
               <a:pPr/>
-              <a:t>3/27/2026</a:t>
+              <a:t>3/28/2026</a:t>
             </a:fld>
             <a:endParaRPr lang="en-US"/>
           </a:p>
@@ -3300,7 +3300,7 @@
           <p:spPr>
             <a:xfrm>
               <a:off x="0" y="1067530"/>
-              <a:ext cx="9149270" cy="971121"/>
+              <a:ext cx="9149270" cy="2021751"/>
             </a:xfrm>
             <a:prstGeom prst="rect">
               <a:avLst/>
@@ -3318,16 +3318,16 @@
                 </a:lnSpc>
               </a:pPr>
               <a:r>
-                <a:rPr lang="en-US" sz="4184" dirty="0">
+                <a:rPr lang="en-US" sz="5000" dirty="0">
                   <a:solidFill>
-                    <a:srgbClr val="D9E9FC"/>
+                    <a:schemeClr val="bg2"/>
                   </a:solidFill>
                   <a:latin typeface="HK Grotesk Light"/>
                   <a:ea typeface="HK Grotesk Light"/>
                   <a:cs typeface="HK Grotesk Light"/>
                   <a:sym typeface="HK Grotesk Light"/>
                 </a:rPr>
-                <a:t>{{description}}</a:t>
+                <a:t>{{description and red bold italic}}</a:t>
               </a:r>
             </a:p>
           </p:txBody>

</xml_diff>